<commit_message>
Add live Tableau Public dashboard link + workbook; finalize deck links
- Publish interactive dashboard to Tableau Public and link it in the README and deck
- Add the packaged Tableau workbook (customer_behaviour_dashboard.twbx)
- Fill slide 10 links (GitHub repo + live dashboard)

Co-Authored-By: Claude Opus 4.8 <noreply@anthropic.com>
</commit_message>
<xml_diff>
--- a/presentation/Customer_Shopping_Behavior_Presentation.pptx
+++ b/presentation/Customer_Shopping_Behavior_Presentation.pptx
@@ -2091,7 +2091,7 @@
         </p:nvSpPr>
         <p:spPr>
           <a:xfrm>
-            <a:off x="640080" y="4297680"/>
+            <a:off x="640080" y="4206240"/>
             <a:ext cx="5486400" cy="365760"/>
           </a:xfrm>
           <a:prstGeom prst="rect">
@@ -2130,8 +2130,8 @@
         </p:nvSpPr>
         <p:spPr>
           <a:xfrm>
-            <a:off x="640080" y="4754880"/>
-            <a:ext cx="6858000" cy="914400"/>
+            <a:off x="640080" y="4663440"/>
+            <a:ext cx="6583680" cy="1188720"/>
           </a:xfrm>
           <a:prstGeom prst="rect">
             <a:avLst/>
@@ -2145,7 +2145,7 @@
           <a:p>
             <a:pPr indent="0" marL="0">
               <a:lnSpc>
-                <a:spcPct val="130000"/>
+                <a:spcPct val="150000"/>
               </a:lnSpc>
               <a:buNone/>
             </a:pPr>
@@ -2158,29 +2158,38 @@
                 <a:ea typeface="Calibri" pitchFamily="34" charset="-122"/>
                 <a:cs typeface="Calibri" pitchFamily="34" charset="-120"/>
               </a:rPr>
-              <a:t>GitHub repository</a:t>
+              <a:t>GitHub repository:  </a:t>
             </a:r>
             <a:pPr indent="0" marL="0">
               <a:lnSpc>
-                <a:spcPct val="130000"/>
+                <a:spcPct val="150000"/>
               </a:lnSpc>
               <a:buNone/>
             </a:pPr>
             <a:r>
-              <a:rPr lang="en-US" sz="1400" i="1" dirty="0">
-                <a:solidFill>
-                  <a:srgbClr val="9FBAB9"/>
+              <a:rPr lang="en-US" sz="1200" u="sng" dirty="0">
+                <a:solidFill>
+                  <a:srgbClr val="8FD3D0"/>
                 </a:solidFill>
                 <a:latin typeface="Calibri" pitchFamily="34" charset="0"/>
                 <a:ea typeface="Calibri" pitchFamily="34" charset="-122"/>
                 <a:cs typeface="Calibri" pitchFamily="34" charset="-120"/>
-              </a:rPr>
-              <a:t>   —   link added on publication
-</a:t>
-            </a:r>
+                <a:hlinkClick r:id="rId1" invalidUrl="" action="" tgtFrame="" tooltip="" history="1" highlightClick="0" endSnd="0">
+                  <a:extLst>
+                    <a:ext uri="{A12FA001-AC4F-418D-AE19-62706E023703}">
+                      <ahyp:hlinkClr xmlns:ahyp="http://schemas.microsoft.com/office/drawing/2018/hyperlinkcolor" val="tx"/>
+                    </a:ext>
+                  </a:extLst>
+                </a:hlinkClick>
+              </a:rPr>
+              <a:t>github.com/Manas463/customer-shopping-behavior-analysis</a:t>
+            </a:r>
+            <a:endParaRPr lang="en-US" sz="1400" dirty="0"/>
+          </a:p>
+          <a:p>
             <a:pPr indent="0" marL="0">
               <a:lnSpc>
-                <a:spcPct val="130000"/>
+                <a:spcPct val="150000"/>
               </a:lnSpc>
               <a:buNone/>
             </a:pPr>
@@ -2193,24 +2202,31 @@
                 <a:ea typeface="Calibri" pitchFamily="34" charset="-122"/>
                 <a:cs typeface="Calibri" pitchFamily="34" charset="-120"/>
               </a:rPr>
-              <a:t>Live dashboard / full report</a:t>
+              <a:t>Live dashboard:  </a:t>
             </a:r>
             <a:pPr indent="0" marL="0">
               <a:lnSpc>
-                <a:spcPct val="130000"/>
+                <a:spcPct val="150000"/>
               </a:lnSpc>
               <a:buNone/>
             </a:pPr>
             <a:r>
-              <a:rPr lang="en-US" sz="1400" i="1" dirty="0">
-                <a:solidFill>
-                  <a:srgbClr val="9FBAB9"/>
+              <a:rPr lang="en-US" sz="1200" u="sng" dirty="0">
+                <a:solidFill>
+                  <a:srgbClr val="8FD3D0"/>
                 </a:solidFill>
                 <a:latin typeface="Calibri" pitchFamily="34" charset="0"/>
                 <a:ea typeface="Calibri" pitchFamily="34" charset="-122"/>
                 <a:cs typeface="Calibri" pitchFamily="34" charset="-120"/>
-              </a:rPr>
-              <a:t>   —   link added on publication</a:t>
+                <a:hlinkClick r:id="rId2" invalidUrl="" action="" tgtFrame="" tooltip="" history="1" highlightClick="0" endSnd="0">
+                  <a:extLst>
+                    <a:ext uri="{A12FA001-AC4F-418D-AE19-62706E023703}">
+                      <ahyp:hlinkClr xmlns:ahyp="http://schemas.microsoft.com/office/drawing/2018/hyperlinkcolor" val="tx"/>
+                    </a:ext>
+                  </a:extLst>
+                </a:hlinkClick>
+              </a:rPr>
+              <a:t>View the interactive dashboard on Tableau Public  →</a:t>
             </a:r>
             <a:endParaRPr lang="en-US" sz="1400" dirty="0"/>
           </a:p>
@@ -2254,7 +2270,7 @@
           <p:nvPr/>
         </p:nvPicPr>
         <p:blipFill>
-          <a:blip r:embed="rId1"/>
+          <a:blip r:embed="rId3"/>
           <a:stretch>
             <a:fillRect/>
           </a:stretch>

</xml_diff>